<commit_message>
Proofread hle slides page by page with Gemini
</commit_message>
<xml_diff>
--- a/slides/datasets-in-10-minutes-hle.pptx
+++ b/slides/datasets-in-10-minutes-hle.pptx
@@ -7690,8 +7690,8 @@
         </p:blipFill>
         <p:spPr>
           <a:xfrm>
-            <a:off x="548640" y="2116438"/>
-            <a:ext cx="8046720" cy="1793019"/>
+            <a:off x="548640" y="2142267"/>
+            <a:ext cx="8046720" cy="1741360"/>
           </a:xfrm>
           <a:prstGeom prst="rect">
             <a:avLst/>
@@ -9086,7 +9086,7 @@
                 <a:spcPct val="110000"/>
               </a:lnSpc>
               <a:buNone/>
-              <a:defRPr sz="2800" b="0">
+              <a:defRPr sz="2500" b="0">
                 <a:solidFill>
                   <a:srgbClr val="303437"/>
                 </a:solidFill>
@@ -9094,15 +9094,15 @@
               </a:defRPr>
             </a:pPr>
             <a:r>
-              <a:rPr sz="2800" b="1" lang="ja-JP" altLang="en-US">
-                <a:solidFill>
-                  <a:srgbClr val="303437"/>
-                </a:solidFill>
-                <a:latin typeface="Noto Sans"/>
-                <a:ea typeface="Noto Sans CJK JP"/>
-                <a:cs typeface="Noto Sans"/>
-              </a:rPr>
-              <a:t>正解率は採点された正解数を全問数で割る</a:t>
+              <a:rPr sz="2500" b="1" lang="ja-JP" altLang="en-US">
+                <a:solidFill>
+                  <a:srgbClr val="303437"/>
+                </a:solidFill>
+                <a:latin typeface="Noto Sans"/>
+                <a:ea typeface="Noto Sans CJK JP"/>
+                <a:cs typeface="Noto Sans"/>
+              </a:rPr>
+              <a:t>正解率は採点された正解数を全問数で割って求める</a:t>
             </a:r>
           </a:p>
         </p:txBody>
@@ -10293,7 +10293,7 @@
                 <a:ea typeface="Noto Sans CJK JP"/>
                 <a:cs typeface="Noto Sans"/>
               </a:rPr>
-              <a:t>「90%の確信がある」と答える問題群で実際の正解が10%なら、強く過信している。</a:t>
+              <a:t>「90%の確信がある」と答える問題群で実際の正解率が10%なら、強く過信している。</a:t>
             </a:r>
           </a:p>
           <a:p>
@@ -13560,7 +13560,7 @@
                 <a:ea typeface="Noto Sans CJK JP"/>
                 <a:cs typeface="Noto Sans"/>
               </a:rPr>
-              <a:t>参加者は主に大学教員、研究者、大学院修了者で、各分野の専門性を使って難問を作成した。</a:t>
+              <a:t>参加者は主に大学教員、研究者、大学院修了者で、各分野の専門性を活かして難問を作成した。</a:t>
             </a:r>
           </a:p>
           <a:p>
@@ -13590,7 +13590,7 @@
                 <a:ea typeface="Noto Sans CJK JP"/>
                 <a:cs typeface="Noto Sans"/>
               </a:rPr>
-              <a:t>質問は英語で、明確で解けること、答えを短く確認できること、検索だけで容易に見つからないことが求められた。</a:t>
+              <a:t>質問は英語とし、明確で解けること、答えが短く確認しやすいこと、検索だけで容易に見つからないことが求められた。</a:t>
             </a:r>
           </a:p>
         </p:txBody>
@@ -15395,7 +15395,7 @@
                 <a:ea typeface="Noto Sans CJK JP"/>
                 <a:cs typeface="Noto Sans"/>
               </a:rPr>
-              <a:t>短答式は全モデルが解けないこと、選択式は偶然の正解を考慮して一つのモデル以外が解けないことを投稿条件とした。</a:t>
+              <a:t>短答式は全モデルが解けないこと、選択式は偶然の正解を考慮して正解できるモデルが一つ以下であることを投稿条件とした。</a:t>
             </a:r>
           </a:p>
         </p:txBody>
@@ -15650,7 +15650,7 @@
                 <a:ea typeface="Noto Sans CJK JP"/>
                 <a:cs typeface="Noto Sans"/>
               </a:rPr>
-              <a:t>第一段階では、関連分野の大学院学位を持つ査読者が、設問ごとに1〜3件のレビューを行い、作者が修正する。</a:t>
+              <a:t>第一段階では、関連分野の大学院学位を持つ査読者が設問ごとに1〜3件のレビューを行い、作成者が修正した。</a:t>
             </a:r>
           </a:p>
           <a:p>
@@ -15680,7 +15680,7 @@
                 <a:ea typeface="Noto Sans CJK JP"/>
                 <a:cs typeface="Noto Sans"/>
               </a:rPr>
-              <a:t>第二段階では、主催者や訓練された専門家が、基準を満たす良質な問題を最終承認する。</a:t>
+              <a:t>第二段階では、主催者や訓練された専門家が、基準を満たす良質な問題を最終承認した。</a:t>
             </a:r>
           </a:p>
           <a:p>
@@ -15710,7 +15710,7 @@
                 <a:ea typeface="Noto Sans CJK JP"/>
                 <a:cs typeface="Noto Sans"/>
               </a:rPr>
-              <a:t>公開後も、コミュニティの指摘、著者への照会、追加の監査によって誤りや曖昧さを修正した。</a:t>
+              <a:t>公開後も、コミュニティの指摘、作成者への照会、追加の監査によって誤りや曖昧さを修正した。</a:t>
             </a:r>
           </a:p>
         </p:txBody>
@@ -16014,7 +16014,7 @@
                           <a:ea typeface="Noto Sans CJK JP"/>
                           <a:cs typeface="Noto Sans"/>
                         </a:rPr>
-                        <a:t>仕組み</a:t>
+                        <a:t>区分・対象</a:t>
                       </a:r>
                     </a:p>
                   </a:txBody>
@@ -16070,7 +16070,7 @@
                           <a:ea typeface="Noto Sans CJK JP"/>
                           <a:cs typeface="Noto Sans"/>
                         </a:rPr>
-                        <a:t>原著の内容</a:t>
+                        <a:t>報酬・特典</a:t>
                       </a:r>
                     </a:p>
                   </a:txBody>
@@ -16656,7 +16656,7 @@
                 <a:spcPct val="110000"/>
               </a:lnSpc>
               <a:buNone/>
-              <a:defRPr sz="2800" b="0">
+              <a:defRPr sz="2500" b="0">
                 <a:solidFill>
                   <a:srgbClr val="303437"/>
                 </a:solidFill>
@@ -16664,15 +16664,15 @@
               </a:defRPr>
             </a:pPr>
             <a:r>
-              <a:rPr sz="2800" b="1" lang="ja-JP" altLang="en-US">
-                <a:solidFill>
-                  <a:srgbClr val="303437"/>
-                </a:solidFill>
-                <a:latin typeface="Noto Sans"/>
-                <a:ea typeface="Noto Sans CJK JP"/>
-                <a:cs typeface="Noto Sans"/>
-              </a:rPr>
-              <a:t>数学が41%を占め、分野ごとの重みは違う</a:t>
+              <a:rPr sz="2500" b="1" lang="ja-JP" altLang="en-US">
+                <a:solidFill>
+                  <a:srgbClr val="303437"/>
+                </a:solidFill>
+                <a:latin typeface="Noto Sans"/>
+                <a:ea typeface="Noto Sans CJK JP"/>
+                <a:cs typeface="Noto Sans"/>
+              </a:rPr>
+              <a:t>数学が41%を占め、分野ごとの比重は大きく異なる</a:t>
             </a:r>
           </a:p>
         </p:txBody>
@@ -16792,7 +16792,7 @@
                 <a:ea typeface="Noto Sans CJK JP"/>
                 <a:cs typeface="Noto Sans"/>
               </a:rPr>
-              <a:t>Phanら（2026）。分野別の構成比（%）。</a:t>
+              <a:t>Phanら（2026）による分野別構成比（%）</a:t>
             </a:r>
           </a:p>
         </p:txBody>
@@ -18123,7 +18123,7 @@
                 <a:ea typeface="Noto Sans CJK JP"/>
                 <a:cs typeface="Noto Sans"/>
               </a:rPr>
-              <a:t>Hugging Faceで利用登録が必要な状態。許可されたアカウントで認証してから実行する。</a:t>
+              <a:t>Hugging Faceで利用登録が必要。許可されたアカウントで認証してから実行する。</a:t>
             </a:r>
           </a:p>
         </p:txBody>
@@ -19572,7 +19572,7 @@
                 <a:spcPct val="110000"/>
               </a:lnSpc>
               <a:buNone/>
-              <a:defRPr sz="2800" b="0">
+              <a:defRPr sz="2500" b="0">
                 <a:solidFill>
                   <a:srgbClr val="303437"/>
                 </a:solidFill>
@@ -19580,15 +19580,15 @@
               </a:defRPr>
             </a:pPr>
             <a:r>
-              <a:rPr sz="2800" b="1" lang="ja-JP" altLang="en-US">
-                <a:solidFill>
-                  <a:srgbClr val="303437"/>
-                </a:solidFill>
-                <a:latin typeface="Noto Sans"/>
-                <a:ea typeface="Noto Sans CJK JP"/>
-                <a:cs typeface="Noto Sans"/>
-              </a:rPr>
-              <a:t>追加例：二つの圏の間の個数を求める</a:t>
+              <a:rPr sz="2500" b="1" lang="ja-JP" altLang="en-US">
+                <a:solidFill>
+                  <a:srgbClr val="303437"/>
+                </a:solidFill>
+                <a:latin typeface="Noto Sans"/>
+                <a:ea typeface="Noto Sans CJK JP"/>
+                <a:cs typeface="Noto Sans"/>
+              </a:rPr>
+              <a:t>追加例：二つの圏の間の自然余変換の個数を求める</a:t>
             </a:r>
           </a:p>
         </p:txBody>
@@ -19928,7 +19928,7 @@
                 <a:ea typeface="Noto Sans CJK JP"/>
                 <a:cs typeface="Noto Sans"/>
               </a:rPr>
-              <a:t>数学の例は、定義を理解して個数を答える</a:t>
+              <a:t>追加例：定義を理解して個数を答える</a:t>
             </a:r>
           </a:p>
         </p:txBody>
@@ -20665,7 +20665,7 @@
                 <a:ea typeface="Noto Sans CJK JP"/>
                 <a:cs typeface="Noto Sans"/>
               </a:rPr>
-              <a:t>計算機科学の例は、収束するグラフ類を選ぶ</a:t>
+              <a:t>計算機科学の例では、収束するグラフ類を選ぶ</a:t>
             </a:r>
           </a:p>
         </p:txBody>
@@ -21455,7 +21455,7 @@
                 <a:ea typeface="Noto Sans CJK JP"/>
                 <a:cs typeface="Noto Sans"/>
               </a:rPr>
-              <a:t>詩篇104:7のヘブライ語本文について、子音音で終わる閉音節を列挙する。</a:t>
+              <a:t>詩篇104:7のヘブライ語本文について、子音で終わる閉音節を列挙する。</a:t>
             </a:r>
           </a:p>
           <a:p>
@@ -26381,7 +26381,7 @@
                 <a:ea typeface="Noto Sans CJK JP"/>
                 <a:cs typeface="Noto Sans"/>
               </a:rPr>
-              <a:t>配布データには問題以外の情報も付く</a:t>
+              <a:t>配布データには問題以外の情報も含まれる</a:t>
             </a:r>
           </a:p>
         </p:txBody>
@@ -28193,7 +28193,7 @@
                           <a:ea typeface="Noto Sans CJK JP"/>
                           <a:cs typeface="Noto Sans"/>
                         </a:rPr>
-                        <a:t>経路</a:t>
+                        <a:t>設定項目</a:t>
                       </a:r>
                     </a:p>
                   </a:txBody>
@@ -30202,7 +30202,7 @@
                 <a:ea typeface="Noto Sans CJK JP"/>
                 <a:cs typeface="Noto Sans"/>
               </a:rPr>
-              <a:t>既存の試験が高得点になり、難問を集めた</a:t>
+              <a:t>既存の試験が高得点化し、難問を集めた</a:t>
             </a:r>
           </a:p>
         </p:txBody>

</xml_diff>

<commit_message>
slides(hle): refine Japanese wording and pair translations
</commit_message>
<xml_diff>
--- a/slides/datasets-in-10-minutes-hle.pptx
+++ b/slides/datasets-in-10-minutes-hle.pptx
@@ -8900,7 +8900,7 @@
                 <a:ea typeface="Noto Sans CJK JP"/>
                 <a:cs typeface="Noto Sans"/>
               </a:rPr>
-              <a:t>原著の評価ではo3-mini-2025-01-31を採点に使った。</a:t>
+              <a:t>公開時の評価ではo3-mini-2025-01-31を採点に使った。</a:t>
             </a:r>
           </a:p>
         </p:txBody>
@@ -10323,7 +10323,7 @@
                 <a:ea typeface="Noto Sans CJK JP"/>
                 <a:cs typeface="Noto Sans"/>
               </a:rPr>
-              <a:t>原著は、正解率に加えてRMS calibration errorを報告する。予測した確信度と実際の正解率のずれを測る指標で、低いほどよい。</a:t>
+              <a:t>正解率に加えてRMS calibration errorを報告する。予測した確信度と実際の正解率のずれを測る指標で、低いほどよい。</a:t>
             </a:r>
           </a:p>
         </p:txBody>
@@ -13495,7 +13495,7 @@
                 <a:ea typeface="Noto Sans CJK JP"/>
                 <a:cs typeface="Noto Sans"/>
               </a:rPr>
-              <a:t>原著では、約1,000人の専門家が、50か国・500超の機関から参加したと報告している。</a:t>
+              <a:t>約1,000人の専門家が、50か国・500超の機関から参加したと報告されている。</a:t>
             </a:r>
           </a:p>
           <a:p>
@@ -14675,7 +14675,7 @@
                           <a:ea typeface="Noto Sans CJK JP"/>
                           <a:cs typeface="Noto Sans"/>
                         </a:rPr>
-                        <a:t>原著の規模・処理</a:t>
+                        <a:t>構築時の規模・処理</a:t>
                       </a:r>
                     </a:p>
                   </a:txBody>
@@ -16964,7 +16964,7 @@
                 <a:ea typeface="Noto Sans CJK JP"/>
                 <a:cs typeface="Noto Sans"/>
               </a:rPr>
-              <a:t>原著の付録では、200問ずつの二つの監査と修正を経た公開版の専門家不一致率を15.4%と推定している。</a:t>
+              <a:t>論文の付録では、200問ずつの二つの監査と修正を経た公開版の専門家不一致率を15.4%と推定している。</a:t>
             </a:r>
           </a:p>
           <a:p>
@@ -17620,7 +17620,7 @@
                 <a:ea typeface="Noto Sans CJK JP"/>
                 <a:cs typeface="Noto Sans"/>
               </a:rPr>
-              <a:t>原著の公開版は2,500問で、HLE-Rollingは問題を継続的に追加・修正する動的な版である。</a:t>
+              <a:t>論文で扱う公開版は2,500問で、HLE-Rollingは問題を継続的に追加・修正する動的な版である。</a:t>
             </a:r>
           </a:p>
           <a:p>
@@ -24557,7 +24557,7 @@
                 <a:ea typeface="Noto Sans CJK JP"/>
                 <a:cs typeface="Noto Sans"/>
               </a:rPr>
-              <a:t>原著の公開版は2,500問。文章だけの問題に加え、図や画像を読む問題を含む。</a:t>
+              <a:t>論文で扱う公開版は2,500問。文章だけの問題に加え、図や画像を読む問題を含む。</a:t>
             </a:r>
           </a:p>
           <a:p>
@@ -29115,7 +29115,7 @@
                 <a:ea typeface="Noto Sans CJK JP"/>
                 <a:cs typeface="Noto Sans"/>
               </a:rPr>
-              <a:t>質問の作成には多数の専門家が参加した。原著は運営チームとデータ作成への貢献者を区別して列挙する。</a:t>
+              <a:t>質問の作成には多数の専門家が参加した。論文では運営チームとデータ作成への貢献者を区別して列挙する。</a:t>
             </a:r>
           </a:p>
           <a:p>
@@ -29511,7 +29511,7 @@
                 <a:ea typeface="Noto Sans CJK JP"/>
                 <a:cs typeface="Noto Sans"/>
               </a:rPr>
-              <a:t>HLEの収集・審査・構成・登場時のモデル評価を報告する原著。</a:t>
+              <a:t>HLEの収集・審査・構成・登場時のモデル評価を報告する論文。</a:t>
             </a:r>
           </a:p>
           <a:p>
@@ -31430,7 +31430,7 @@
                           <a:ea typeface="Noto Sans CJK JP"/>
                           <a:cs typeface="Noto Sans"/>
                         </a:rPr>
-                        <a:t>原著の構成</a:t>
+                        <a:t>公開時の構成</a:t>
                       </a:r>
                     </a:p>
                   </a:txBody>

</xml_diff>

<commit_message>
slides(hle): keep evaluation context independent of release timing
</commit_message>
<xml_diff>
--- a/slides/datasets-in-10-minutes-hle.pptx
+++ b/slides/datasets-in-10-minutes-hle.pptx
@@ -8900,7 +8900,7 @@
                 <a:ea typeface="Noto Sans CJK JP"/>
                 <a:cs typeface="Noto Sans"/>
               </a:rPr>
-              <a:t>公開時の評価ではo3-mini-2025-01-31を採点に使った。</a:t>
+              <a:t>評価ではo3-mini-2025-01-31を採点に使った。</a:t>
             </a:r>
           </a:p>
         </p:txBody>
@@ -31430,7 +31430,7 @@
                           <a:ea typeface="Noto Sans CJK JP"/>
                           <a:cs typeface="Noto Sans"/>
                         </a:rPr>
-                        <a:t>公開時の構成</a:t>
+                        <a:t>公開版の構成</a:t>
                       </a:r>
                     </a:p>
                   </a:txBody>

</xml_diff>